<commit_message>
feat(round3): deliver all three major improvements, visual asset inspector, dense vector embeddings, browser extension & native figma plugin, report and slides
</commit_message>
<xml_diff>
--- a/Verity_Round1_Deck_Complete.pptx
+++ b/Verity_Round1_Deck_Complete.pptx
@@ -2404,7 +2404,7 @@
                 </a:solidFill>
                 <a:latin typeface="Arial"/>
               </a:rPr>
-              <a:t>Round 2: The Build   |   Live: cosmicboom.xyz &amp; verity-brand-governance.vercel.app</a:t>
+              <a:t>Round 3: Product Completion (Top 100) | Live: cosmicboom.xyz &amp; verity-brand-governance.vercel.app</a:t>
             </a:r>
             <a:endParaRPr lang="en-US" sz="950" dirty="0"/>
           </a:p>
@@ -3628,7 +3628,7 @@
                 </a:solidFill>
                 <a:latin typeface="Georgia"/>
               </a:rPr>
-              <a:t>Repo: github.com/AstroNewz/VERITY</a:t>
+              <a:t>Repo: github.com/IshanShukla-1/VERITY</a:t>
             </a:r>
           </a:p>
         </p:txBody>
@@ -3763,7 +3763,7 @@
                 </a:solidFill>
                 <a:latin typeface="Georgia"/>
               </a:rPr>
-              <a:t>Deliverables: PDF Report,</a:t>
+              <a:t>Deliverables: Round 3 PDF Report,</a:t>
             </a:r>
             <a:endParaRPr lang="en-US" sz="1300" dirty="0"/>
           </a:p>
@@ -3775,7 +3775,7 @@
                 </a:solidFill>
                 <a:latin typeface="Georgia"/>
               </a:rPr>
-              <a:t>Interactive Verifier &amp; Tour Guide</a:t>
+              <a:t>Interactive Verifier, Extension &amp; Figma Plugin</a:t>
             </a:r>
           </a:p>
         </p:txBody>
@@ -4003,7 +4003,7 @@
                 </a:solidFill>
                 <a:latin typeface="Arial"/>
               </a:rPr>
-              <a:t>Team BraKet | CodeAxis Round 2: The Build | Verified 24/7 Keepalive Active</a:t>
+              <a:t>Team BraKet | CodeAxis Round 3: Product Completion | Top 100 Finalist</a:t>
             </a:r>
             <a:endParaRPr lang="en-US" sz="1000" dirty="0"/>
           </a:p>
@@ -4969,7 +4969,7 @@
                 </a:solidFill>
                 <a:latin typeface="Courier New"/>
               </a:rPr>
-              <a:t>ROUND 2 BUILD VALIDATION  Dual-set benchmark on 24 planted defects: 100% core recall, 0 false alarms.</a:t>
+              <a:t>ROUND 3 PRODUCT COMPLETION  Dual-set benchmark on 24 planted defects: 100% precision, 0 false alarms, 16/16 Pytest passing.</a:t>
             </a:r>
             <a:endParaRPr lang="en-US" sz="950" dirty="0"/>
           </a:p>
@@ -6229,7 +6229,7 @@
                 </a:solidFill>
                 <a:latin typeface="Courier New"/>
               </a:rPr>
-              <a:t>ZERO-ASSISTANCE JUDGE TOUR  In-situ guided tutorial with 4 persona tracks (Creator, Reviewer, Owner, All) &amp; spotlight box.</a:t>
+              <a:t>ZERO-ASSISTANCE JUDGE TOUR  In-situ guided tutorial with 4 persona tracks (Creator, Reviewer, Owner, All) &amp; sandbox simulator.</a:t>
             </a:r>
             <a:endParaRPr lang="en-US" sz="900" dirty="0"/>
           </a:p>
@@ -6489,7 +6489,7 @@
                 </a:solidFill>
                 <a:latin typeface="Arial"/>
               </a:rPr>
-              <a:t>Text, image alt-text, hex contrast, docx, pdf.</a:t>
+              <a:t>Text, graphics, banners, alt-text, hex contrast, docx, pdf.</a:t>
             </a:r>
             <a:endParaRPr lang="en-US" sz="1000" dirty="0"/>
           </a:p>
@@ -6698,7 +6698,7 @@
                 </a:solidFill>
                 <a:latin typeface="Georgia"/>
               </a:rPr>
-              <a:t>Claim Ledger</a:t>
+              <a:t>Claim Ledger™</a:t>
             </a:r>
             <a:endParaRPr lang="en-US" sz="1300" dirty="0"/>
           </a:p>
@@ -6735,7 +6735,7 @@
                 </a:solidFill>
                 <a:latin typeface="Arial"/>
               </a:rPr>
-              <a:t>Verifies claims &amp; 30-day expiry against evidence.</a:t>
+              <a:t>Dense vector matching (bge-small-en) &amp; 30-day expiry check.</a:t>
             </a:r>
             <a:endParaRPr lang="en-US" sz="1000" dirty="0"/>
           </a:p>
@@ -7290,7 +7290,7 @@
                 </a:solidFill>
                 <a:latin typeface="Georgia"/>
               </a:rPr>
-              <a:t>Core features: Round 2 working build</a:t>
+              <a:t>Core features: Round 3 production platform</a:t>
             </a:r>
             <a:endParaRPr lang="en-US" sz="2800" dirty="0"/>
           </a:p>
@@ -7601,7 +7601,7 @@
                 </a:solidFill>
                 <a:latin typeface="Georgia"/>
               </a:rPr>
-              <a:t>Claim Ledger™</a:t>
+              <a:t>Vector Claim Ledger™</a:t>
             </a:r>
             <a:endParaRPr lang="en-US" sz="1350" dirty="0"/>
           </a:p>
@@ -7638,7 +7638,7 @@
                 </a:solidFill>
                 <a:latin typeface="Arial"/>
               </a:rPr>
-              <a:t>4-state lifecycle (Verified, Expires Soon &lt;30d, Expired, Unsupported).</a:t>
+              <a:t>BAAI/bge-small-en-v1.5 dense cosine similarity with digit conflict guard.</a:t>
             </a:r>
             <a:endParaRPr lang="en-US" sz="1050" dirty="0"/>
           </a:p>
@@ -7774,7 +7774,7 @@
                 </a:solidFill>
                 <a:latin typeface="Georgia"/>
               </a:rPr>
-              <a:t>Deterministic + AI</a:t>
+              <a:t>Asset Vision Engine</a:t>
             </a:r>
             <a:endParaRPr lang="en-US" sz="1350" dirty="0"/>
           </a:p>
@@ -7811,7 +7811,7 @@
                 </a:solidFill>
                 <a:latin typeface="Arial"/>
               </a:rPr>
-              <a:t>Regex casing &amp; codenames run first; Groq Llama 3.3 evaluates tone.</a:t>
+              <a:t>16-bin brand palette tokenization, WCAG 2.1 AA contrast, and safe zones.</a:t>
             </a:r>
             <a:endParaRPr lang="en-US" sz="1050" dirty="0"/>
           </a:p>
@@ -7947,7 +7947,7 @@
                 </a:solidFill>
                 <a:latin typeface="Georgia"/>
               </a:rPr>
-              <a:t>Citing Findings</a:t>
+              <a:t>Client Extensions</a:t>
             </a:r>
             <a:endParaRPr lang="en-US" sz="1350" dirty="0"/>
           </a:p>
@@ -7984,7 +7984,7 @@
                 </a:solidFill>
                 <a:latin typeface="Arial"/>
               </a:rPr>
-              <a:t>Quotes exact substring, rule ID, and official Brand Book page citation.</a:t>
+              <a:t>Chromium Manifest V3 extension, native Figma plugin &amp; web sandbox.</a:t>
             </a:r>
             <a:endParaRPr lang="en-US" sz="1050" dirty="0"/>
           </a:p>
@@ -11548,7 +11548,7 @@
                 </a:solidFill>
                 <a:latin typeface="Arial"/>
               </a:rPr>
-              <a:t>Privacy Gateway: Zero PII transit to external LLMs</a:t>
+              <a:t>Dense Embeddings: BAAI/bge-small-en ONNX cosine vector matcher</a:t>
             </a:r>
             <a:endParaRPr lang="en-US" sz="850" dirty="0"/>
           </a:p>
@@ -11566,7 +11566,7 @@
                 </a:solidFill>
                 <a:latin typeface="Arial"/>
               </a:rPr>
-              <a:t>Groq Cloud SDK: Sub-second (&lt;800ms) Llama 3.3 review</a:t>
+              <a:t>Vision Engine: 16-bin quantization &amp; WCAG contrast</a:t>
             </a:r>
             <a:endParaRPr lang="en-US" sz="850" dirty="0"/>
           </a:p>
@@ -11584,7 +11584,7 @@
                 </a:solidFill>
                 <a:latin typeface="Arial"/>
               </a:rPr>
-              <a:t>Intent Lock: In-memory token restorer &amp; hook preservation</a:t>
+              <a:t>Groq AI: Sub-second (&lt;800ms) Llama 3.3 tone review</a:t>
             </a:r>
             <a:endParaRPr lang="en-US" sz="850" dirty="0"/>
           </a:p>
@@ -12520,7 +12520,7 @@
                 </a:solidFill>
                 <a:latin typeface="Georgia"/>
               </a:rPr>
-              <a:t>Round 1 to Round 2 Progress &amp; Round 3 Roadmap</a:t>
+              <a:t>Round 2 Commitments Delivered 100% in Round 3</a:t>
             </a:r>
             <a:endParaRPr lang="en-US" sz="2800" dirty="0"/>
           </a:p>
@@ -12723,7 +12723,7 @@
                 </a:solidFill>
                 <a:latin typeface="Courier New"/>
               </a:rPr>
-              <a:t>ROUND 2: BUILD (LIVE NOW)</a:t>
+              <a:t>ROUND 2: BUILD (DONE)</a:t>
             </a:r>
             <a:endParaRPr lang="en-US" sz="900" dirty="0"/>
           </a:p>
@@ -12764,7 +12764,7 @@
                 </a:solidFill>
                 <a:latin typeface="Arial"/>
               </a:rPr>
-              <a:t>Full working workflow</a:t>
+              <a:t>Working core workflow</a:t>
             </a:r>
             <a:endParaRPr lang="en-US" sz="1050" dirty="0"/>
           </a:p>
@@ -12821,7 +12821,7 @@
                 </a:solidFill>
                 <a:latin typeface="Arial"/>
               </a:rPr>
-              <a:t>Publish Passport &amp; Tamper</a:t>
+              <a:t>Publish Passport</a:t>
             </a:r>
             <a:endParaRPr lang="en-US" sz="1050" dirty="0"/>
           </a:p>
@@ -12840,7 +12840,7 @@
                 </a:solidFill>
                 <a:latin typeface="Arial"/>
               </a:rPr>
-              <a:t>Self-Guided 4-Track Tour</a:t>
+              <a:t>Self-Guided Tour</a:t>
             </a:r>
             <a:endParaRPr lang="en-US" sz="1050" dirty="0"/>
           </a:p>
@@ -12902,7 +12902,7 @@
                 </a:solidFill>
                 <a:latin typeface="Courier New"/>
               </a:rPr>
-              <a:t>ROUND 3: 3 MAJOR ADDS</a:t>
+              <a:t>ROUND 3: DELIVERED (100%)</a:t>
             </a:r>
             <a:endParaRPr lang="en-US" sz="900" dirty="0"/>
           </a:p>
@@ -12943,7 +12943,7 @@
                 </a:solidFill>
                 <a:latin typeface="Arial"/>
               </a:rPr>
-              <a:t>1. Dense Vector Embeddings (pgvector claim matching)</a:t>
+              <a:t>1. Dense Vector Embeddings (fastembed BAAI/bge-small-en ONNX)</a:t>
             </a:r>
             <a:endParaRPr lang="en-US" sz="1050" dirty="0"/>
           </a:p>
@@ -12962,7 +12962,7 @@
                 </a:solidFill>
                 <a:latin typeface="Arial"/>
               </a:rPr>
-              <a:t>2. Multimodal Vision (poster, logo, color review)</a:t>
+              <a:t>2. Multimodal Vision (palette, WCAG 2.1 contrast, safe-zones)</a:t>
             </a:r>
             <a:endParaRPr lang="en-US" sz="1050" dirty="0"/>
           </a:p>
@@ -12981,7 +12981,7 @@
                 </a:solidFill>
                 <a:latin typeface="Arial"/>
               </a:rPr>
-              <a:t>3. Figma &amp; CMS Plugins (in-situ creator checks)</a:t>
+              <a:t>3. Chromium Extension &amp; Native Figma Plugin (+ Web Sandbox)</a:t>
             </a:r>
             <a:endParaRPr lang="en-US" sz="1050" dirty="0"/>
           </a:p>
@@ -13396,7 +13396,7 @@
                 </a:solidFill>
                 <a:latin typeface="Georgia"/>
               </a:rPr>
-              <a:t>12/12</a:t>
+              <a:t>16/16</a:t>
             </a:r>
             <a:endParaRPr lang="en-US" sz="2000" dirty="0"/>
           </a:p>
@@ -13905,7 +13905,7 @@
                 </a:solidFill>
                 <a:latin typeface="Arial"/>
               </a:rPr>
-              <a:t>Round 3 Additions: Substantial algorithmic &amp; multimodal expansions, not cosmetic tweaks.</a:t>
+              <a:t>Round 3 Commitments: All 3 major technical expansions completed and verified.</a:t>
             </a:r>
             <a:endParaRPr lang="en-US" sz="950" dirty="0"/>
           </a:p>

</xml_diff>

<commit_message>
feat(branding): update platform, navigation, and submission decks to Top 50 Finalist
</commit_message>
<xml_diff>
--- a/Verity_Round1_Deck_Complete.pptx
+++ b/Verity_Round1_Deck_Complete.pptx
@@ -2404,7 +2404,7 @@
                 </a:solidFill>
                 <a:latin typeface="Arial"/>
               </a:rPr>
-              <a:t>Round 3: Product Completion (Top 100) | Live: cosmicboom.xyz &amp; verity-brand-governance.vercel.app</a:t>
+              <a:t>Round 3: Product Completion (Top 50 Finalist) | Live: cosmicboom.xyz &amp; verity-brand-governance.vercel.app</a:t>
             </a:r>
             <a:endParaRPr lang="en-US" sz="950" dirty="0"/>
           </a:p>
@@ -4003,7 +4003,7 @@
                 </a:solidFill>
                 <a:latin typeface="Arial"/>
               </a:rPr>
-              <a:t>Team BraKet | CodeAxis Round 3: Product Completion | Top 100 Finalist</a:t>
+              <a:t>Team BraKet | CodeAxis Round 3: Product Completion | Top 50 Finalist</a:t>
             </a:r>
             <a:endParaRPr lang="en-US" sz="1000" dirty="0"/>
           </a:p>

</xml_diff>